<commit_message>
updated setup and functional architecture schema
</commit_message>
<xml_diff>
--- a/doc/architecture.pptx
+++ b/doc/architecture.pptx
@@ -107,6 +107,11 @@
       </a:defRPr>
     </a:lvl9pPr>
   </p:defaultTextStyle>
+  <p:extLst>
+    <p:ext uri="{EFAFB233-063F-42B5-8137-9DF3F51BA10A}">
+      <p15:sldGuideLst xmlns:p15="http://schemas.microsoft.com/office/powerpoint/2012/main"/>
+    </p:ext>
+  </p:extLst>
 </p:presentation>
 </file>
 
@@ -3808,8 +3813,8 @@
         </p:blipFill>
         <p:spPr bwMode="auto">
           <a:xfrm>
-            <a:off x="743976" y="968951"/>
-            <a:ext cx="886019" cy="886019"/>
+            <a:off x="743977" y="968952"/>
+            <a:ext cx="765290" cy="765290"/>
           </a:xfrm>
           <a:prstGeom prst="rect">
             <a:avLst/>
@@ -3856,7 +3861,7 @@
         <p:spPr bwMode="auto">
           <a:xfrm>
             <a:off x="829937" y="4854508"/>
-            <a:ext cx="584680" cy="534920"/>
+            <a:ext cx="505011" cy="462031"/>
           </a:xfrm>
           <a:prstGeom prst="rect">
             <a:avLst/>
@@ -3903,7 +3908,7 @@
         <p:spPr bwMode="auto">
           <a:xfrm>
             <a:off x="759736" y="3352310"/>
-            <a:ext cx="936153" cy="680676"/>
+            <a:ext cx="808593" cy="587927"/>
           </a:xfrm>
           <a:prstGeom prst="rect">
             <a:avLst/>
@@ -3949,8 +3954,8 @@
         </p:blipFill>
         <p:spPr bwMode="auto">
           <a:xfrm>
-            <a:off x="375836" y="2865394"/>
-            <a:ext cx="1217181" cy="361561"/>
+            <a:off x="375837" y="2865394"/>
+            <a:ext cx="1051328" cy="312295"/>
           </a:xfrm>
           <a:prstGeom prst="rect">
             <a:avLst/>
@@ -3997,7 +4002,7 @@
         <p:spPr bwMode="auto">
           <a:xfrm>
             <a:off x="386999" y="2305824"/>
-            <a:ext cx="1194856" cy="281714"/>
+            <a:ext cx="1032045" cy="243328"/>
           </a:xfrm>
           <a:prstGeom prst="rect">
             <a:avLst/>
@@ -4044,7 +4049,7 @@
         <p:spPr bwMode="auto">
           <a:xfrm>
             <a:off x="383793" y="5446497"/>
-            <a:ext cx="1516261" cy="1004886"/>
+            <a:ext cx="1309655" cy="867960"/>
           </a:xfrm>
           <a:prstGeom prst="rect">
             <a:avLst/>
@@ -4075,7 +4080,7 @@
         </p:nvSpPr>
         <p:spPr>
           <a:xfrm>
-            <a:off x="1530634" y="5411456"/>
+            <a:off x="1456746" y="5411456"/>
             <a:ext cx="2946640" cy="530915"/>
           </a:xfrm>
           <a:prstGeom prst="rect">
@@ -4117,8 +4122,8 @@
         </p:nvSpPr>
         <p:spPr>
           <a:xfrm>
-            <a:off x="1530634" y="4054376"/>
-            <a:ext cx="4076950" cy="530915"/>
+            <a:off x="1456746" y="4054376"/>
+            <a:ext cx="3560783" cy="530915"/>
           </a:xfrm>
           <a:prstGeom prst="rect">
             <a:avLst/>
@@ -4133,7 +4138,7 @@
           <a:p>
             <a:r>
               <a:rPr lang="fr-CH" dirty="0"/>
-              <a:t>Dictionnaire Historique de la Suisse (DHS)</a:t>
+              <a:t>Dictionnaire Historique de la Suisse</a:t>
             </a:r>
           </a:p>
           <a:p>
@@ -4159,7 +4164,7 @@
         </p:nvSpPr>
         <p:spPr>
           <a:xfrm>
-            <a:off x="1530634" y="3373700"/>
+            <a:off x="1456746" y="3373700"/>
             <a:ext cx="2367956" cy="530915"/>
           </a:xfrm>
           <a:prstGeom prst="rect">
@@ -4217,8 +4222,8 @@
         </p:blipFill>
         <p:spPr bwMode="auto">
           <a:xfrm>
-            <a:off x="243160" y="3981899"/>
-            <a:ext cx="1346651" cy="756647"/>
+            <a:off x="243161" y="3981900"/>
+            <a:ext cx="1163156" cy="653546"/>
           </a:xfrm>
           <a:prstGeom prst="rect">
             <a:avLst/>
@@ -4249,7 +4254,7 @@
         </p:nvSpPr>
         <p:spPr>
           <a:xfrm>
-            <a:off x="1533840" y="2777462"/>
+            <a:off x="1459952" y="2777462"/>
             <a:ext cx="2364750" cy="530915"/>
           </a:xfrm>
           <a:prstGeom prst="rect">
@@ -4291,7 +4296,7 @@
         </p:nvSpPr>
         <p:spPr>
           <a:xfrm>
-            <a:off x="1558558" y="2181224"/>
+            <a:off x="1484670" y="2181224"/>
             <a:ext cx="2454518" cy="530915"/>
           </a:xfrm>
           <a:prstGeom prst="rect">
@@ -4333,7 +4338,7 @@
         </p:nvSpPr>
         <p:spPr>
           <a:xfrm>
-            <a:off x="1558558" y="1117373"/>
+            <a:off x="1484670" y="1117373"/>
             <a:ext cx="3020379" cy="530915"/>
           </a:xfrm>
           <a:prstGeom prst="rect">
@@ -4375,7 +4380,7 @@
         </p:nvSpPr>
         <p:spPr>
           <a:xfrm>
-            <a:off x="1530634" y="4738546"/>
+            <a:off x="1456746" y="4738546"/>
             <a:ext cx="2081019" cy="530915"/>
           </a:xfrm>
           <a:prstGeom prst="rect">
@@ -4433,7 +4438,7 @@
         <p:spPr bwMode="auto">
           <a:xfrm>
             <a:off x="1255737" y="1648288"/>
-            <a:ext cx="324173" cy="324173"/>
+            <a:ext cx="280001" cy="280001"/>
           </a:xfrm>
           <a:prstGeom prst="rect">
             <a:avLst/>
@@ -4464,7 +4469,7 @@
         </p:nvSpPr>
         <p:spPr>
           <a:xfrm>
-            <a:off x="1558558" y="1585037"/>
+            <a:off x="1484670" y="1585037"/>
             <a:ext cx="3063083" cy="530915"/>
           </a:xfrm>
           <a:prstGeom prst="rect">
@@ -4528,10 +4533,10 @@
       </p:sp>
       <p:sp>
         <p:nvSpPr>
-          <p:cNvPr id="16" name="Rectangle 15">
-            <a:extLst>
-              <a:ext uri="{FF2B5EF4-FFF2-40B4-BE49-F238E27FC236}">
-                <a16:creationId xmlns:a16="http://schemas.microsoft.com/office/drawing/2014/main" id="{1974304C-84BF-1396-F63E-71FBC745A425}"/>
+          <p:cNvPr id="18" name="Flowchart: Multidocument 17">
+            <a:extLst>
+              <a:ext uri="{FF2B5EF4-FFF2-40B4-BE49-F238E27FC236}">
+                <a16:creationId xmlns:a16="http://schemas.microsoft.com/office/drawing/2014/main" id="{149FAC26-B7C0-08E6-B57C-00C8E72F6619}"/>
               </a:ext>
             </a:extLst>
           </p:cNvPr>
@@ -4540,18 +4545,18 @@
         </p:nvSpPr>
         <p:spPr>
           <a:xfrm>
-            <a:off x="7698757" y="663390"/>
-            <a:ext cx="2227572" cy="1309071"/>
-          </a:xfrm>
-          <a:prstGeom prst="rect">
+            <a:off x="7574163" y="3006306"/>
+            <a:ext cx="942975" cy="1047750"/>
+          </a:xfrm>
+          <a:prstGeom prst="flowChartMultidocument">
             <a:avLst/>
           </a:prstGeom>
-          <a:noFill/>
-          <a:ln>
-            <a:solidFill>
-              <a:schemeClr val="tx1"/>
-            </a:solidFill>
-          </a:ln>
+          <a:solidFill>
+            <a:schemeClr val="accent4">
+              <a:lumMod val="40000"/>
+              <a:lumOff val="60000"/>
+            </a:schemeClr>
+          </a:solidFill>
         </p:spPr>
         <p:style>
           <a:lnRef idx="2">
@@ -4580,10 +4585,10 @@
       </p:sp>
       <p:sp>
         <p:nvSpPr>
-          <p:cNvPr id="17" name="TextBox 16">
-            <a:extLst>
-              <a:ext uri="{FF2B5EF4-FFF2-40B4-BE49-F238E27FC236}">
-                <a16:creationId xmlns:a16="http://schemas.microsoft.com/office/drawing/2014/main" id="{E344EF01-0617-1228-554F-DC5CFAEEC3B5}"/>
+          <p:cNvPr id="20" name="TextBox 19">
+            <a:extLst>
+              <a:ext uri="{FF2B5EF4-FFF2-40B4-BE49-F238E27FC236}">
+                <a16:creationId xmlns:a16="http://schemas.microsoft.com/office/drawing/2014/main" id="{443855E6-69B0-7FFA-9C9B-F0D064CB0B87}"/>
               </a:ext>
             </a:extLst>
           </p:cNvPr>
@@ -4592,8 +4597,8 @@
         </p:nvSpPr>
         <p:spPr>
           <a:xfrm>
-            <a:off x="6096348" y="2799714"/>
-            <a:ext cx="1560620" cy="461665"/>
+            <a:off x="7199066" y="4014456"/>
+            <a:ext cx="1635704" cy="461665"/>
           </a:xfrm>
           <a:prstGeom prst="rect">
             <a:avLst/>
@@ -4607,410 +4612,244 @@
           <a:lstStyle/>
           <a:p>
             <a:r>
-              <a:rPr lang="fr-CH" sz="2400" b="1" dirty="0" err="1"/>
-              <a:t>Fetch</a:t>
-            </a:r>
-            <a:r>
               <a:rPr lang="fr-CH" sz="2400" b="1" dirty="0"/>
-              <a:t> </a:t>
-            </a:r>
-            <a:r>
-              <a:rPr lang="fr-CH" sz="2400" b="1" dirty="0" err="1"/>
-              <a:t>skills</a:t>
-            </a:r>
-            <a:endParaRPr lang="fr-CH" sz="2400" b="1" dirty="0"/>
-          </a:p>
-        </p:txBody>
-      </p:sp>
-      <p:sp>
-        <p:nvSpPr>
-          <p:cNvPr id="18" name="Flowchart: Multidocument 17">
-            <a:extLst>
-              <a:ext uri="{FF2B5EF4-FFF2-40B4-BE49-F238E27FC236}">
-                <a16:creationId xmlns:a16="http://schemas.microsoft.com/office/drawing/2014/main" id="{149FAC26-B7C0-08E6-B57C-00C8E72F6619}"/>
-              </a:ext>
-            </a:extLst>
-          </p:cNvPr>
-          <p:cNvSpPr/>
+              <a:t>Documents</a:t>
+            </a:r>
+          </a:p>
+        </p:txBody>
+      </p:sp>
+      <p:sp>
+        <p:nvSpPr>
+          <p:cNvPr id="17" name="TextBox 16">
+            <a:extLst>
+              <a:ext uri="{FF2B5EF4-FFF2-40B4-BE49-F238E27FC236}">
+                <a16:creationId xmlns:a16="http://schemas.microsoft.com/office/drawing/2014/main" id="{E344EF01-0617-1228-554F-DC5CFAEEC3B5}"/>
+              </a:ext>
+            </a:extLst>
+          </p:cNvPr>
+          <p:cNvSpPr txBox="1"/>
           <p:nvPr/>
         </p:nvSpPr>
         <p:spPr>
           <a:xfrm>
-            <a:off x="8242825" y="3352310"/>
-            <a:ext cx="942975" cy="1047750"/>
-          </a:xfrm>
-          <a:prstGeom prst="flowChartMultidocument">
-            <a:avLst/>
-          </a:prstGeom>
-        </p:spPr>
-        <p:style>
-          <a:lnRef idx="2">
-            <a:schemeClr val="accent1">
-              <a:shade val="15000"/>
-            </a:schemeClr>
-          </a:lnRef>
-          <a:fillRef idx="1">
-            <a:schemeClr val="accent1"/>
-          </a:fillRef>
-          <a:effectRef idx="0">
-            <a:schemeClr val="accent1"/>
-          </a:effectRef>
-          <a:fontRef idx="minor">
-            <a:schemeClr val="lt1"/>
-          </a:fontRef>
-        </p:style>
-        <p:txBody>
-          <a:bodyPr rtlCol="0" anchor="ctr"/>
-          <a:lstStyle/>
-          <a:p>
-            <a:pPr algn="ctr"/>
-            <a:endParaRPr lang="fr-CH"/>
-          </a:p>
-        </p:txBody>
-      </p:sp>
-      <p:sp>
-        <p:nvSpPr>
-          <p:cNvPr id="20" name="TextBox 19">
-            <a:extLst>
-              <a:ext uri="{FF2B5EF4-FFF2-40B4-BE49-F238E27FC236}">
-                <a16:creationId xmlns:a16="http://schemas.microsoft.com/office/drawing/2014/main" id="{443855E6-69B0-7FFA-9C9B-F0D064CB0B87}"/>
-              </a:ext>
-            </a:extLst>
-          </p:cNvPr>
-          <p:cNvSpPr txBox="1"/>
-          <p:nvPr/>
-        </p:nvSpPr>
-        <p:spPr>
-          <a:xfrm>
-            <a:off x="7978012" y="4388365"/>
-            <a:ext cx="1635704" cy="461665"/>
+            <a:off x="5282325" y="3209614"/>
+            <a:ext cx="1656574" cy="1235941"/>
           </a:xfrm>
           <a:prstGeom prst="rect">
             <a:avLst/>
           </a:prstGeom>
-          <a:noFill/>
-        </p:spPr>
-        <p:txBody>
-          <a:bodyPr wrap="none" rtlCol="0">
+          <a:solidFill>
+            <a:schemeClr val="accent6">
+              <a:lumMod val="40000"/>
+              <a:lumOff val="60000"/>
+            </a:schemeClr>
+          </a:solidFill>
+        </p:spPr>
+        <p:txBody>
+          <a:bodyPr wrap="square" rtlCol="0">
             <a:spAutoFit/>
           </a:bodyPr>
           <a:lstStyle/>
           <a:p>
+            <a:pPr algn="ctr"/>
+            <a:r>
+              <a:rPr lang="fr-CH" sz="2400" b="1" dirty="0" err="1"/>
+              <a:t>Fetch</a:t>
+            </a:r>
             <a:r>
               <a:rPr lang="fr-CH" sz="2400" b="1" dirty="0"/>
-              <a:t>Documents</a:t>
-            </a:r>
-          </a:p>
-        </p:txBody>
-      </p:sp>
-      <p:sp>
-        <p:nvSpPr>
-          <p:cNvPr id="21" name="Rectangle 20">
-            <a:extLst>
-              <a:ext uri="{FF2B5EF4-FFF2-40B4-BE49-F238E27FC236}">
-                <a16:creationId xmlns:a16="http://schemas.microsoft.com/office/drawing/2014/main" id="{1B3390D3-534B-BF0D-8505-5564D2D4A6C3}"/>
-              </a:ext>
-            </a:extLst>
-          </p:cNvPr>
-          <p:cNvSpPr/>
+              <a:t> </a:t>
+            </a:r>
+            <a:r>
+              <a:rPr lang="fr-CH" sz="2400" b="1" dirty="0" err="1"/>
+              <a:t>skills</a:t>
+            </a:r>
+            <a:endParaRPr lang="fr-CH" sz="2400" b="1" dirty="0"/>
+          </a:p>
+          <a:p>
+            <a:pPr algn="ctr"/>
+            <a:r>
+              <a:rPr lang="fr-CH" sz="1600" dirty="0"/>
+              <a:t>Recherche et télécharge les documents</a:t>
+            </a:r>
+          </a:p>
+        </p:txBody>
+      </p:sp>
+      <p:sp>
+        <p:nvSpPr>
+          <p:cNvPr id="22" name="TextBox 21">
+            <a:extLst>
+              <a:ext uri="{FF2B5EF4-FFF2-40B4-BE49-F238E27FC236}">
+                <a16:creationId xmlns:a16="http://schemas.microsoft.com/office/drawing/2014/main" id="{A4D528F7-4547-2DDA-5FB1-6CC4A455D708}"/>
+              </a:ext>
+            </a:extLst>
+          </p:cNvPr>
+          <p:cNvSpPr txBox="1"/>
           <p:nvPr/>
         </p:nvSpPr>
         <p:spPr>
           <a:xfrm>
-            <a:off x="5852253" y="2799714"/>
-            <a:ext cx="1804715" cy="2129551"/>
+            <a:off x="7023333" y="662111"/>
+            <a:ext cx="2168285" cy="1107996"/>
           </a:xfrm>
           <a:prstGeom prst="rect">
             <a:avLst/>
           </a:prstGeom>
-          <a:noFill/>
-          <a:ln>
+          <a:solidFill>
+            <a:schemeClr val="accent6">
+              <a:lumMod val="40000"/>
+              <a:lumOff val="60000"/>
+            </a:schemeClr>
+          </a:solidFill>
+        </p:spPr>
+        <p:txBody>
+          <a:bodyPr wrap="square" rtlCol="0">
+            <a:spAutoFit/>
+          </a:bodyPr>
+          <a:lstStyle/>
+          <a:p>
+            <a:pPr algn="ctr"/>
+            <a:r>
+              <a:rPr lang="fr-CH" sz="2400" b="1" dirty="0"/>
+              <a:t>Transformation </a:t>
+            </a:r>
+            <a:r>
+              <a:rPr lang="fr-CH" sz="2400" b="1" dirty="0" err="1"/>
+              <a:t>skills</a:t>
+            </a:r>
+            <a:br>
+              <a:rPr lang="fr-CH" sz="2400" b="1" dirty="0"/>
+            </a:br>
+            <a:r>
+              <a:rPr lang="fr-CH" sz="1600" dirty="0"/>
+              <a:t>(OCR, traduction, …)</a:t>
+            </a:r>
+            <a:endParaRPr lang="fr-CH" dirty="0"/>
+          </a:p>
+        </p:txBody>
+      </p:sp>
+      <p:sp>
+        <p:nvSpPr>
+          <p:cNvPr id="24" name="TextBox 23">
+            <a:extLst>
+              <a:ext uri="{FF2B5EF4-FFF2-40B4-BE49-F238E27FC236}">
+                <a16:creationId xmlns:a16="http://schemas.microsoft.com/office/drawing/2014/main" id="{0F1B0B62-A513-5ED8-B91E-EC3333B763CA}"/>
+              </a:ext>
+            </a:extLst>
+          </p:cNvPr>
+          <p:cNvSpPr txBox="1"/>
+          <p:nvPr/>
+        </p:nvSpPr>
+        <p:spPr>
+          <a:xfrm>
+            <a:off x="9220567" y="2021380"/>
+            <a:ext cx="1388499" cy="1200329"/>
+          </a:xfrm>
+          <a:prstGeom prst="rect">
+            <a:avLst/>
+          </a:prstGeom>
+          <a:solidFill>
+            <a:schemeClr val="accent6">
+              <a:lumMod val="40000"/>
+              <a:lumOff val="60000"/>
+            </a:schemeClr>
+          </a:solidFill>
+        </p:spPr>
+        <p:txBody>
+          <a:bodyPr wrap="square" rtlCol="0">
+            <a:spAutoFit/>
+          </a:bodyPr>
+          <a:lstStyle/>
+          <a:p>
+            <a:pPr algn="ctr"/>
+            <a:r>
+              <a:rPr lang="fr-CH" sz="2400" b="1" dirty="0" err="1"/>
+              <a:t>Query</a:t>
+            </a:r>
+            <a:r>
+              <a:rPr lang="fr-CH" sz="2400" b="1" dirty="0"/>
+              <a:t> </a:t>
+            </a:r>
+            <a:r>
+              <a:rPr lang="fr-CH" sz="2400" b="1" dirty="0" err="1"/>
+              <a:t>skills</a:t>
+            </a:r>
+            <a:r>
+              <a:rPr lang="fr-CH" sz="2400" b="1" dirty="0"/>
+              <a:t> (RAG)</a:t>
+            </a:r>
+          </a:p>
+        </p:txBody>
+      </p:sp>
+      <p:sp>
+        <p:nvSpPr>
+          <p:cNvPr id="27" name="TextBox 26">
+            <a:extLst>
+              <a:ext uri="{FF2B5EF4-FFF2-40B4-BE49-F238E27FC236}">
+                <a16:creationId xmlns:a16="http://schemas.microsoft.com/office/drawing/2014/main" id="{47AD83CE-05D8-3926-C567-CA569C76DB74}"/>
+              </a:ext>
+            </a:extLst>
+          </p:cNvPr>
+          <p:cNvSpPr txBox="1"/>
+          <p:nvPr/>
+        </p:nvSpPr>
+        <p:spPr>
+          <a:xfrm>
+            <a:off x="9183380" y="3667042"/>
+            <a:ext cx="1465390" cy="830997"/>
+          </a:xfrm>
+          <a:prstGeom prst="rect">
+            <a:avLst/>
+          </a:prstGeom>
+          <a:solidFill>
+            <a:schemeClr val="accent6">
+              <a:lumMod val="40000"/>
+              <a:lumOff val="60000"/>
+            </a:schemeClr>
+          </a:solidFill>
+        </p:spPr>
+        <p:txBody>
+          <a:bodyPr wrap="square" rtlCol="0">
+            <a:spAutoFit/>
+          </a:bodyPr>
+          <a:lstStyle/>
+          <a:p>
+            <a:pPr algn="ctr"/>
+            <a:r>
+              <a:rPr lang="fr-CH" sz="2400" b="1" dirty="0"/>
+              <a:t>Agents d’analyse</a:t>
+            </a:r>
+          </a:p>
+        </p:txBody>
+      </p:sp>
+      <p:sp>
+        <p:nvSpPr>
+          <p:cNvPr id="28" name="Left Brace 27">
+            <a:extLst>
+              <a:ext uri="{FF2B5EF4-FFF2-40B4-BE49-F238E27FC236}">
+                <a16:creationId xmlns:a16="http://schemas.microsoft.com/office/drawing/2014/main" id="{C298B2CC-044D-120A-A8AA-2AB4FFE6E2C6}"/>
+              </a:ext>
+            </a:extLst>
+          </p:cNvPr>
+          <p:cNvSpPr/>
+          <p:nvPr/>
+        </p:nvSpPr>
+        <p:spPr>
+          <a:xfrm flipH="1">
+            <a:off x="4836061" y="1411960"/>
+            <a:ext cx="338487" cy="4704257"/>
+          </a:xfrm>
+          <a:prstGeom prst="leftBrace">
+            <a:avLst>
+              <a:gd name="adj1" fmla="val 32252"/>
+              <a:gd name="adj2" fmla="val 50000"/>
+            </a:avLst>
+          </a:prstGeom>
+          <a:ln w="57150">
             <a:solidFill>
               <a:schemeClr val="tx1"/>
             </a:solidFill>
           </a:ln>
-        </p:spPr>
-        <p:style>
-          <a:lnRef idx="2">
-            <a:schemeClr val="accent1">
-              <a:shade val="15000"/>
-            </a:schemeClr>
-          </a:lnRef>
-          <a:fillRef idx="1">
-            <a:schemeClr val="accent1"/>
-          </a:fillRef>
-          <a:effectRef idx="0">
-            <a:schemeClr val="accent1"/>
-          </a:effectRef>
-          <a:fontRef idx="minor">
-            <a:schemeClr val="lt1"/>
-          </a:fontRef>
-        </p:style>
-        <p:txBody>
-          <a:bodyPr rtlCol="0" anchor="ctr"/>
-          <a:lstStyle/>
-          <a:p>
-            <a:pPr algn="ctr"/>
-            <a:endParaRPr lang="fr-CH"/>
-          </a:p>
-        </p:txBody>
-      </p:sp>
-      <p:sp>
-        <p:nvSpPr>
-          <p:cNvPr id="22" name="TextBox 21">
-            <a:extLst>
-              <a:ext uri="{FF2B5EF4-FFF2-40B4-BE49-F238E27FC236}">
-                <a16:creationId xmlns:a16="http://schemas.microsoft.com/office/drawing/2014/main" id="{A4D528F7-4547-2DDA-5FB1-6CC4A455D708}"/>
-              </a:ext>
-            </a:extLst>
-          </p:cNvPr>
-          <p:cNvSpPr txBox="1"/>
-          <p:nvPr/>
-        </p:nvSpPr>
-        <p:spPr>
-          <a:xfrm>
-            <a:off x="7758043" y="770490"/>
-            <a:ext cx="2168285" cy="1107996"/>
-          </a:xfrm>
-          <a:prstGeom prst="rect">
-            <a:avLst/>
-          </a:prstGeom>
-          <a:noFill/>
-        </p:spPr>
-        <p:txBody>
-          <a:bodyPr wrap="square" rtlCol="0">
-            <a:spAutoFit/>
-          </a:bodyPr>
-          <a:lstStyle/>
-          <a:p>
-            <a:pPr algn="ctr"/>
-            <a:r>
-              <a:rPr lang="fr-CH" sz="2400" b="1" dirty="0"/>
-              <a:t>Transformation </a:t>
-            </a:r>
-            <a:r>
-              <a:rPr lang="fr-CH" sz="2400" b="1" dirty="0" err="1"/>
-              <a:t>skills</a:t>
-            </a:r>
-            <a:br>
-              <a:rPr lang="fr-CH" sz="2400" b="1" dirty="0"/>
-            </a:br>
-            <a:r>
-              <a:rPr lang="fr-CH" b="1" dirty="0"/>
-              <a:t>(OCR, traduction, …)</a:t>
-            </a:r>
-          </a:p>
-        </p:txBody>
-      </p:sp>
-      <p:sp>
-        <p:nvSpPr>
-          <p:cNvPr id="23" name="Rectangle 22">
-            <a:extLst>
-              <a:ext uri="{FF2B5EF4-FFF2-40B4-BE49-F238E27FC236}">
-                <a16:creationId xmlns:a16="http://schemas.microsoft.com/office/drawing/2014/main" id="{90A73A3C-057F-8827-1902-0ADB18A2D041}"/>
-              </a:ext>
-            </a:extLst>
-          </p:cNvPr>
-          <p:cNvSpPr/>
-          <p:nvPr/>
-        </p:nvSpPr>
-        <p:spPr>
-          <a:xfrm>
-            <a:off x="9878660" y="2774464"/>
-            <a:ext cx="2227572" cy="1309071"/>
-          </a:xfrm>
-          <a:prstGeom prst="rect">
-            <a:avLst/>
-          </a:prstGeom>
-          <a:noFill/>
-          <a:ln>
-            <a:solidFill>
-              <a:schemeClr val="tx1"/>
-            </a:solidFill>
-          </a:ln>
-        </p:spPr>
-        <p:style>
-          <a:lnRef idx="2">
-            <a:schemeClr val="accent1">
-              <a:shade val="15000"/>
-            </a:schemeClr>
-          </a:lnRef>
-          <a:fillRef idx="1">
-            <a:schemeClr val="accent1"/>
-          </a:fillRef>
-          <a:effectRef idx="0">
-            <a:schemeClr val="accent1"/>
-          </a:effectRef>
-          <a:fontRef idx="minor">
-            <a:schemeClr val="lt1"/>
-          </a:fontRef>
-        </p:style>
-        <p:txBody>
-          <a:bodyPr rtlCol="0" anchor="ctr"/>
-          <a:lstStyle/>
-          <a:p>
-            <a:pPr algn="ctr"/>
-            <a:endParaRPr lang="fr-CH"/>
-          </a:p>
-        </p:txBody>
-      </p:sp>
-      <p:sp>
-        <p:nvSpPr>
-          <p:cNvPr id="24" name="TextBox 23">
-            <a:extLst>
-              <a:ext uri="{FF2B5EF4-FFF2-40B4-BE49-F238E27FC236}">
-                <a16:creationId xmlns:a16="http://schemas.microsoft.com/office/drawing/2014/main" id="{0F1B0B62-A513-5ED8-B91E-EC3333B763CA}"/>
-              </a:ext>
-            </a:extLst>
-          </p:cNvPr>
-          <p:cNvSpPr txBox="1"/>
-          <p:nvPr/>
-        </p:nvSpPr>
-        <p:spPr>
-          <a:xfrm>
-            <a:off x="9937946" y="2881564"/>
-            <a:ext cx="2168285" cy="830997"/>
-          </a:xfrm>
-          <a:prstGeom prst="rect">
-            <a:avLst/>
-          </a:prstGeom>
-          <a:noFill/>
-        </p:spPr>
-        <p:txBody>
-          <a:bodyPr wrap="square" rtlCol="0">
-            <a:spAutoFit/>
-          </a:bodyPr>
-          <a:lstStyle/>
-          <a:p>
-            <a:pPr algn="ctr"/>
-            <a:r>
-              <a:rPr lang="fr-CH" sz="2400" b="1" dirty="0" err="1"/>
-              <a:t>Query</a:t>
-            </a:r>
-            <a:r>
-              <a:rPr lang="fr-CH" sz="2400" b="1" dirty="0"/>
-              <a:t> </a:t>
-            </a:r>
-            <a:r>
-              <a:rPr lang="fr-CH" sz="2400" b="1" dirty="0" err="1"/>
-              <a:t>skills</a:t>
-            </a:r>
-            <a:r>
-              <a:rPr lang="fr-CH" sz="2400" b="1" dirty="0"/>
-              <a:t> (RAG)</a:t>
-            </a:r>
-          </a:p>
-        </p:txBody>
-      </p:sp>
-      <p:sp>
-        <p:nvSpPr>
-          <p:cNvPr id="26" name="Rectangle 25">
-            <a:extLst>
-              <a:ext uri="{FF2B5EF4-FFF2-40B4-BE49-F238E27FC236}">
-                <a16:creationId xmlns:a16="http://schemas.microsoft.com/office/drawing/2014/main" id="{03610503-AC5F-9653-09B8-48A017F721A4}"/>
-              </a:ext>
-            </a:extLst>
-          </p:cNvPr>
-          <p:cNvSpPr/>
-          <p:nvPr/>
-        </p:nvSpPr>
-        <p:spPr>
-          <a:xfrm>
-            <a:off x="9867041" y="4239455"/>
-            <a:ext cx="2227572" cy="1309071"/>
-          </a:xfrm>
-          <a:prstGeom prst="rect">
-            <a:avLst/>
-          </a:prstGeom>
-          <a:noFill/>
-          <a:ln>
-            <a:solidFill>
-              <a:schemeClr val="tx1"/>
-            </a:solidFill>
-          </a:ln>
-        </p:spPr>
-        <p:style>
-          <a:lnRef idx="2">
-            <a:schemeClr val="accent1">
-              <a:shade val="15000"/>
-            </a:schemeClr>
-          </a:lnRef>
-          <a:fillRef idx="1">
-            <a:schemeClr val="accent1"/>
-          </a:fillRef>
-          <a:effectRef idx="0">
-            <a:schemeClr val="accent1"/>
-          </a:effectRef>
-          <a:fontRef idx="minor">
-            <a:schemeClr val="lt1"/>
-          </a:fontRef>
-        </p:style>
-        <p:txBody>
-          <a:bodyPr rtlCol="0" anchor="ctr"/>
-          <a:lstStyle/>
-          <a:p>
-            <a:pPr algn="ctr"/>
-            <a:endParaRPr lang="fr-CH"/>
-          </a:p>
-        </p:txBody>
-      </p:sp>
-      <p:sp>
-        <p:nvSpPr>
-          <p:cNvPr id="27" name="TextBox 26">
-            <a:extLst>
-              <a:ext uri="{FF2B5EF4-FFF2-40B4-BE49-F238E27FC236}">
-                <a16:creationId xmlns:a16="http://schemas.microsoft.com/office/drawing/2014/main" id="{47AD83CE-05D8-3926-C567-CA569C76DB74}"/>
-              </a:ext>
-            </a:extLst>
-          </p:cNvPr>
-          <p:cNvSpPr txBox="1"/>
-          <p:nvPr/>
-        </p:nvSpPr>
-        <p:spPr>
-          <a:xfrm>
-            <a:off x="9926328" y="4286055"/>
-            <a:ext cx="2168285" cy="830997"/>
-          </a:xfrm>
-          <a:prstGeom prst="rect">
-            <a:avLst/>
-          </a:prstGeom>
-          <a:noFill/>
-        </p:spPr>
-        <p:txBody>
-          <a:bodyPr wrap="square" rtlCol="0">
-            <a:spAutoFit/>
-          </a:bodyPr>
-          <a:lstStyle/>
-          <a:p>
-            <a:pPr algn="ctr"/>
-            <a:r>
-              <a:rPr lang="fr-CH" sz="2400" b="1" dirty="0"/>
-              <a:t>Agents d’analyse</a:t>
-            </a:r>
-          </a:p>
-        </p:txBody>
-      </p:sp>
-      <p:sp>
-        <p:nvSpPr>
-          <p:cNvPr id="28" name="Left Brace 27">
-            <a:extLst>
-              <a:ext uri="{FF2B5EF4-FFF2-40B4-BE49-F238E27FC236}">
-                <a16:creationId xmlns:a16="http://schemas.microsoft.com/office/drawing/2014/main" id="{C298B2CC-044D-120A-A8AA-2AB4FFE6E2C6}"/>
-              </a:ext>
-            </a:extLst>
-          </p:cNvPr>
-          <p:cNvSpPr/>
-          <p:nvPr/>
-        </p:nvSpPr>
-        <p:spPr>
-          <a:xfrm flipH="1">
-            <a:off x="5367190" y="1435137"/>
-            <a:ext cx="338487" cy="4704257"/>
-          </a:xfrm>
-          <a:prstGeom prst="leftBrace">
-            <a:avLst/>
-          </a:prstGeom>
-          <a:ln w="57150"/>
         </p:spPr>
         <p:style>
           <a:lnRef idx="1">
@@ -5046,20 +4885,23 @@
           </p:cNvPr>
           <p:cNvCxnSpPr>
             <a:cxnSpLocks/>
-            <a:stCxn id="21" idx="3"/>
+            <a:stCxn id="17" idx="3"/>
             <a:endCxn id="18" idx="1"/>
           </p:cNvCxnSpPr>
           <p:nvPr/>
         </p:nvCxnSpPr>
         <p:spPr>
-          <a:xfrm>
-            <a:off x="7656968" y="3864490"/>
-            <a:ext cx="585857" cy="11695"/>
+          <a:xfrm flipV="1">
+            <a:off x="6938899" y="3530181"/>
+            <a:ext cx="635264" cy="297404"/>
           </a:xfrm>
           <a:prstGeom prst="straightConnector1">
             <a:avLst/>
           </a:prstGeom>
-          <a:ln>
+          <a:ln w="38100">
+            <a:solidFill>
+              <a:schemeClr val="tx1"/>
+            </a:solidFill>
             <a:tailEnd type="triangle"/>
           </a:ln>
         </p:spPr>
@@ -5090,19 +4932,22 @@
           <p:cNvCxnSpPr>
             <a:cxnSpLocks/>
             <a:stCxn id="18" idx="0"/>
-            <a:endCxn id="16" idx="2"/>
+            <a:endCxn id="22" idx="2"/>
           </p:cNvCxnSpPr>
           <p:nvPr/>
         </p:nvCxnSpPr>
         <p:spPr>
-          <a:xfrm flipV="1">
-            <a:off x="8779186" y="1972461"/>
-            <a:ext cx="33357" cy="1379849"/>
+          <a:xfrm flipH="1" flipV="1">
+            <a:off x="8107476" y="1770107"/>
+            <a:ext cx="3048" cy="1236199"/>
           </a:xfrm>
           <a:prstGeom prst="straightConnector1">
             <a:avLst/>
           </a:prstGeom>
-          <a:ln>
+          <a:ln w="38100">
+            <a:solidFill>
+              <a:schemeClr val="tx1"/>
+            </a:solidFill>
             <a:headEnd type="triangle"/>
             <a:tailEnd type="triangle"/>
           </a:ln>
@@ -5134,18 +4979,22 @@
           <p:cNvCxnSpPr>
             <a:cxnSpLocks/>
             <a:stCxn id="18" idx="3"/>
+            <a:endCxn id="24" idx="1"/>
           </p:cNvCxnSpPr>
           <p:nvPr/>
         </p:nvCxnSpPr>
         <p:spPr>
           <a:xfrm flipV="1">
-            <a:off x="9185800" y="3574630"/>
-            <a:ext cx="594767" cy="301555"/>
+            <a:off x="8517138" y="2621545"/>
+            <a:ext cx="703429" cy="908636"/>
           </a:xfrm>
           <a:prstGeom prst="straightConnector1">
             <a:avLst/>
           </a:prstGeom>
-          <a:ln>
+          <a:ln w="38100">
+            <a:solidFill>
+              <a:schemeClr val="tx1"/>
+            </a:solidFill>
             <a:tailEnd type="triangle"/>
           </a:ln>
         </p:spPr>
@@ -5176,19 +5025,22 @@
           <p:cNvCxnSpPr>
             <a:cxnSpLocks/>
             <a:stCxn id="18" idx="3"/>
-            <a:endCxn id="26" idx="1"/>
+            <a:endCxn id="27" idx="1"/>
           </p:cNvCxnSpPr>
           <p:nvPr/>
         </p:nvCxnSpPr>
         <p:spPr>
           <a:xfrm>
-            <a:off x="9185800" y="3876185"/>
-            <a:ext cx="681241" cy="1017806"/>
+            <a:off x="8517138" y="3530181"/>
+            <a:ext cx="666242" cy="552360"/>
           </a:xfrm>
           <a:prstGeom prst="straightConnector1">
             <a:avLst/>
           </a:prstGeom>
-          <a:ln>
+          <a:ln w="38100">
+            <a:solidFill>
+              <a:schemeClr val="tx1"/>
+            </a:solidFill>
             <a:tailEnd type="triangle"/>
           </a:ln>
         </p:spPr>
@@ -5221,12 +5073,18 @@
         </p:nvSpPr>
         <p:spPr>
           <a:xfrm>
-            <a:off x="10404671" y="5826654"/>
+            <a:off x="11102199" y="3006306"/>
             <a:ext cx="942975" cy="1047750"/>
           </a:xfrm>
           <a:prstGeom prst="flowChartMultidocument">
             <a:avLst/>
           </a:prstGeom>
+          <a:solidFill>
+            <a:schemeClr val="accent6">
+              <a:lumMod val="40000"/>
+              <a:lumOff val="60000"/>
+            </a:schemeClr>
+          </a:solidFill>
         </p:spPr>
         <p:style>
           <a:lnRef idx="2">
@@ -5267,7 +5125,7 @@
         </p:nvSpPr>
         <p:spPr>
           <a:xfrm>
-            <a:off x="9095017" y="6205389"/>
+            <a:off x="10859288" y="4052086"/>
             <a:ext cx="1309654" cy="461665"/>
           </a:xfrm>
           <a:prstGeom prst="rect">
@@ -5299,20 +5157,23 @@
           </p:cNvPr>
           <p:cNvCxnSpPr>
             <a:cxnSpLocks/>
-            <a:stCxn id="26" idx="2"/>
-            <a:endCxn id="57" idx="0"/>
+            <a:stCxn id="27" idx="3"/>
+            <a:endCxn id="57" idx="1"/>
           </p:cNvCxnSpPr>
           <p:nvPr/>
         </p:nvCxnSpPr>
         <p:spPr>
-          <a:xfrm flipH="1">
-            <a:off x="10941032" y="5548526"/>
-            <a:ext cx="39795" cy="278128"/>
+          <a:xfrm flipV="1">
+            <a:off x="10648770" y="3530181"/>
+            <a:ext cx="453429" cy="552360"/>
           </a:xfrm>
           <a:prstGeom prst="straightConnector1">
             <a:avLst/>
           </a:prstGeom>
-          <a:ln>
+          <a:ln w="38100">
+            <a:solidFill>
+              <a:schemeClr val="tx1"/>
+            </a:solidFill>
             <a:tailEnd type="triangle"/>
           </a:ln>
         </p:spPr>
@@ -5331,6 +5192,108 @@
           </a:fontRef>
         </p:style>
       </p:cxnSp>
+      <p:cxnSp>
+        <p:nvCxnSpPr>
+          <p:cNvPr id="49" name="Straight Arrow Connector 48">
+            <a:extLst>
+              <a:ext uri="{FF2B5EF4-FFF2-40B4-BE49-F238E27FC236}">
+                <a16:creationId xmlns:a16="http://schemas.microsoft.com/office/drawing/2014/main" id="{73469F7C-C5B4-3A7D-51B7-B3B51C7E3F43}"/>
+              </a:ext>
+            </a:extLst>
+          </p:cNvPr>
+          <p:cNvCxnSpPr>
+            <a:cxnSpLocks/>
+            <a:stCxn id="24" idx="3"/>
+            <a:endCxn id="57" idx="1"/>
+          </p:cNvCxnSpPr>
+          <p:nvPr/>
+        </p:nvCxnSpPr>
+        <p:spPr>
+          <a:xfrm>
+            <a:off x="10609066" y="2621545"/>
+            <a:ext cx="493133" cy="908636"/>
+          </a:xfrm>
+          <a:prstGeom prst="straightConnector1">
+            <a:avLst/>
+          </a:prstGeom>
+          <a:ln w="38100">
+            <a:solidFill>
+              <a:schemeClr val="tx1"/>
+            </a:solidFill>
+            <a:tailEnd type="triangle"/>
+          </a:ln>
+        </p:spPr>
+        <p:style>
+          <a:lnRef idx="1">
+            <a:schemeClr val="accent1"/>
+          </a:lnRef>
+          <a:fillRef idx="0">
+            <a:schemeClr val="accent1"/>
+          </a:fillRef>
+          <a:effectRef idx="0">
+            <a:schemeClr val="accent1"/>
+          </a:effectRef>
+          <a:fontRef idx="minor">
+            <a:schemeClr val="tx1"/>
+          </a:fontRef>
+        </p:style>
+      </p:cxnSp>
+      <p:sp>
+        <p:nvSpPr>
+          <p:cNvPr id="53" name="TextBox 52">
+            <a:extLst>
+              <a:ext uri="{FF2B5EF4-FFF2-40B4-BE49-F238E27FC236}">
+                <a16:creationId xmlns:a16="http://schemas.microsoft.com/office/drawing/2014/main" id="{07404A88-E5B2-071F-E2BE-4B429F08E877}"/>
+              </a:ext>
+            </a:extLst>
+          </p:cNvPr>
+          <p:cNvSpPr txBox="1"/>
+          <p:nvPr/>
+        </p:nvSpPr>
+        <p:spPr>
+          <a:xfrm>
+            <a:off x="5282325" y="4606664"/>
+            <a:ext cx="6744915" cy="646331"/>
+          </a:xfrm>
+          <a:prstGeom prst="rect">
+            <a:avLst/>
+          </a:prstGeom>
+          <a:solidFill>
+            <a:schemeClr val="tx2">
+              <a:lumMod val="20000"/>
+              <a:lumOff val="80000"/>
+            </a:schemeClr>
+          </a:solidFill>
+        </p:spPr>
+        <p:txBody>
+          <a:bodyPr wrap="square" rtlCol="0">
+            <a:spAutoFit/>
+          </a:bodyPr>
+          <a:lstStyle/>
+          <a:p>
+            <a:pPr algn="ctr"/>
+            <a:r>
+              <a:rPr lang="fr-CH" sz="2000" b="1" dirty="0"/>
+              <a:t>Plateforme agentique (GitHub </a:t>
+            </a:r>
+            <a:r>
+              <a:rPr lang="fr-CH" sz="2000" b="1" dirty="0" err="1"/>
+              <a:t>Copilot</a:t>
+            </a:r>
+            <a:r>
+              <a:rPr lang="fr-CH" sz="2000" b="1" dirty="0"/>
+              <a:t>, Claude Code, …)</a:t>
+            </a:r>
+          </a:p>
+          <a:p>
+            <a:pPr algn="ctr"/>
+            <a:r>
+              <a:rPr lang="fr-CH" sz="1600" dirty="0"/>
+              <a:t>Dialogue avec l’historien pour l’aider dans ses recherches</a:t>
+            </a:r>
+          </a:p>
+        </p:txBody>
+      </p:sp>
     </p:spTree>
     <p:extLst>
       <p:ext uri="{BB962C8B-B14F-4D97-AF65-F5344CB8AC3E}">

</xml_diff>

<commit_message>
updated functional architecture schema
</commit_message>
<xml_diff>
--- a/doc/architecture.pptx
+++ b/doc/architecture.pptx
@@ -3813,7 +3813,7 @@
         </p:blipFill>
         <p:spPr bwMode="auto">
           <a:xfrm>
-            <a:off x="743977" y="968952"/>
+            <a:off x="721362" y="1025176"/>
             <a:ext cx="765290" cy="765290"/>
           </a:xfrm>
           <a:prstGeom prst="rect">
@@ -4437,7 +4437,7 @@
         </p:blipFill>
         <p:spPr bwMode="auto">
           <a:xfrm>
-            <a:off x="1255737" y="1648288"/>
+            <a:off x="1182304" y="1648175"/>
             <a:ext cx="280001" cy="280001"/>
           </a:xfrm>
           <a:prstGeom prst="rect">
@@ -4545,7 +4545,7 @@
         </p:nvSpPr>
         <p:spPr>
           <a:xfrm>
-            <a:off x="7574163" y="3006306"/>
+            <a:off x="7835370" y="3006306"/>
             <a:ext cx="942975" cy="1047750"/>
           </a:xfrm>
           <a:prstGeom prst="flowChartMultidocument">
@@ -4597,7 +4597,7 @@
         </p:nvSpPr>
         <p:spPr>
           <a:xfrm>
-            <a:off x="7199066" y="4014456"/>
+            <a:off x="7467409" y="4086146"/>
             <a:ext cx="1635704" cy="461665"/>
           </a:xfrm>
           <a:prstGeom prst="rect">
@@ -4632,7 +4632,7 @@
         </p:nvSpPr>
         <p:spPr>
           <a:xfrm>
-            <a:off x="5282325" y="3209614"/>
+            <a:off x="5251347" y="2410332"/>
             <a:ext cx="1656574" cy="1235941"/>
           </a:xfrm>
           <a:prstGeom prst="rect">
@@ -4689,8 +4689,8 @@
         </p:nvSpPr>
         <p:spPr>
           <a:xfrm>
-            <a:off x="7023333" y="662111"/>
-            <a:ext cx="2168285" cy="1107996"/>
+            <a:off x="5267713" y="3764088"/>
+            <a:ext cx="2168285" cy="707886"/>
           </a:xfrm>
           <a:prstGeom prst="rect">
             <a:avLst/>
@@ -4710,8 +4710,12 @@
           <a:p>
             <a:pPr algn="ctr"/>
             <a:r>
+              <a:rPr lang="fr-CH" sz="2400" b="1" dirty="0" err="1"/>
+              <a:t>Transform</a:t>
+            </a:r>
+            <a:r>
               <a:rPr lang="fr-CH" sz="2400" b="1" dirty="0"/>
-              <a:t>Transformation </a:t>
+              <a:t> </a:t>
             </a:r>
             <a:r>
               <a:rPr lang="fr-CH" sz="2400" b="1" dirty="0" err="1"/>
@@ -4742,8 +4746,8 @@
         </p:nvSpPr>
         <p:spPr>
           <a:xfrm>
-            <a:off x="9220567" y="2021380"/>
-            <a:ext cx="1388499" cy="1200329"/>
+            <a:off x="9167014" y="2275539"/>
+            <a:ext cx="1465390" cy="1138773"/>
           </a:xfrm>
           <a:prstGeom prst="rect">
             <a:avLst/>
@@ -4774,10 +4778,18 @@
               <a:rPr lang="fr-CH" sz="2400" b="1" dirty="0" err="1"/>
               <a:t>skills</a:t>
             </a:r>
-            <a:r>
+            <a:br>
               <a:rPr lang="fr-CH" sz="2400" b="1" dirty="0"/>
-              <a:t> (RAG)</a:t>
-            </a:r>
+            </a:br>
+            <a:r>
+              <a:rPr lang="fr-CH" sz="2000" b="1" dirty="0"/>
+              <a:t> </a:t>
+            </a:r>
+            <a:r>
+              <a:rPr lang="fr-CH" sz="1600" dirty="0"/>
+              <a:t>(RAG)</a:t>
+            </a:r>
+            <a:endParaRPr lang="fr-CH" sz="2400" dirty="0"/>
           </a:p>
         </p:txBody>
       </p:sp>
@@ -4842,10 +4854,10 @@
           <a:prstGeom prst="leftBrace">
             <a:avLst>
               <a:gd name="adj1" fmla="val 32252"/>
-              <a:gd name="adj2" fmla="val 50000"/>
+              <a:gd name="adj2" fmla="val 35118"/>
             </a:avLst>
           </a:prstGeom>
-          <a:ln w="57150">
+          <a:ln w="28575">
             <a:solidFill>
               <a:schemeClr val="tx1"/>
             </a:solidFill>
@@ -4891,9 +4903,9 @@
           <p:nvPr/>
         </p:nvCxnSpPr>
         <p:spPr>
-          <a:xfrm flipV="1">
-            <a:off x="6938899" y="3530181"/>
-            <a:ext cx="635264" cy="297404"/>
+          <a:xfrm>
+            <a:off x="6907921" y="3028303"/>
+            <a:ext cx="927449" cy="501878"/>
           </a:xfrm>
           <a:prstGeom prst="straightConnector1">
             <a:avLst/>
@@ -4931,15 +4943,15 @@
           </p:cNvPr>
           <p:cNvCxnSpPr>
             <a:cxnSpLocks/>
-            <a:stCxn id="18" idx="0"/>
-            <a:endCxn id="22" idx="2"/>
+            <a:stCxn id="18" idx="1"/>
+            <a:endCxn id="22" idx="3"/>
           </p:cNvCxnSpPr>
           <p:nvPr/>
         </p:nvCxnSpPr>
         <p:spPr>
-          <a:xfrm flipH="1" flipV="1">
-            <a:off x="8107476" y="1770107"/>
-            <a:ext cx="3048" cy="1236199"/>
+          <a:xfrm flipH="1">
+            <a:off x="7435998" y="3530181"/>
+            <a:ext cx="399372" cy="587850"/>
           </a:xfrm>
           <a:prstGeom prst="straightConnector1">
             <a:avLst/>
@@ -4985,8 +4997,8 @@
         </p:nvCxnSpPr>
         <p:spPr>
           <a:xfrm flipV="1">
-            <a:off x="8517138" y="2621545"/>
-            <a:ext cx="703429" cy="908636"/>
+            <a:off x="8778345" y="2844926"/>
+            <a:ext cx="388669" cy="685255"/>
           </a:xfrm>
           <a:prstGeom prst="straightConnector1">
             <a:avLst/>
@@ -5031,8 +5043,8 @@
         </p:nvCxnSpPr>
         <p:spPr>
           <a:xfrm>
-            <a:off x="8517138" y="3530181"/>
-            <a:ext cx="666242" cy="552360"/>
+            <a:off x="8778345" y="3530181"/>
+            <a:ext cx="405035" cy="552360"/>
           </a:xfrm>
           <a:prstGeom prst="straightConnector1">
             <a:avLst/>
@@ -5080,9 +5092,9 @@
             <a:avLst/>
           </a:prstGeom>
           <a:solidFill>
-            <a:schemeClr val="accent6">
-              <a:lumMod val="40000"/>
-              <a:lumOff val="60000"/>
+            <a:schemeClr val="accent2">
+              <a:lumMod val="60000"/>
+              <a:lumOff val="40000"/>
             </a:schemeClr>
           </a:solidFill>
         </p:spPr>
@@ -5210,8 +5222,8 @@
         </p:nvCxnSpPr>
         <p:spPr>
           <a:xfrm>
-            <a:off x="10609066" y="2621545"/>
-            <a:ext cx="493133" cy="908636"/>
+            <a:off x="10632404" y="2844926"/>
+            <a:ext cx="469795" cy="685255"/>
           </a:xfrm>
           <a:prstGeom prst="straightConnector1">
             <a:avLst/>
@@ -5260,8 +5272,8 @@
           </a:prstGeom>
           <a:solidFill>
             <a:schemeClr val="tx2">
-              <a:lumMod val="20000"/>
-              <a:lumOff val="80000"/>
+              <a:lumMod val="40000"/>
+              <a:lumOff val="60000"/>
             </a:schemeClr>
           </a:solidFill>
         </p:spPr>
@@ -5291,6 +5303,46 @@
               <a:rPr lang="fr-CH" sz="1600" dirty="0"/>
               <a:t>Dialogue avec l’historien pour l’aider dans ses recherches</a:t>
             </a:r>
+          </a:p>
+        </p:txBody>
+      </p:sp>
+      <p:sp>
+        <p:nvSpPr>
+          <p:cNvPr id="40" name="TextBox 39">
+            <a:extLst>
+              <a:ext uri="{FF2B5EF4-FFF2-40B4-BE49-F238E27FC236}">
+                <a16:creationId xmlns:a16="http://schemas.microsoft.com/office/drawing/2014/main" id="{27DDA71A-5FD6-7F2C-EAAC-35EC4D47F1FD}"/>
+              </a:ext>
+            </a:extLst>
+          </p:cNvPr>
+          <p:cNvSpPr txBox="1"/>
+          <p:nvPr/>
+        </p:nvSpPr>
+        <p:spPr>
+          <a:xfrm>
+            <a:off x="7337681" y="888740"/>
+            <a:ext cx="1938351" cy="523220"/>
+          </a:xfrm>
+          <a:prstGeom prst="rect">
+            <a:avLst/>
+          </a:prstGeom>
+          <a:noFill/>
+        </p:spPr>
+        <p:txBody>
+          <a:bodyPr wrap="none" rtlCol="0">
+            <a:spAutoFit/>
+          </a:bodyPr>
+          <a:lstStyle/>
+          <a:p>
+            <a:r>
+              <a:rPr lang="fr-CH" sz="2800" b="1" dirty="0"/>
+              <a:t>Corpus-</a:t>
+            </a:r>
+            <a:r>
+              <a:rPr lang="fr-CH" sz="2800" b="1" dirty="0" err="1"/>
+              <a:t>lens</a:t>
+            </a:r>
+            <a:endParaRPr lang="fr-CH" sz="2800" b="1" dirty="0"/>
           </a:p>
         </p:txBody>
       </p:sp>

</xml_diff>